<commit_message>
feat: add height fallback, notebooklm integration, layouts, and LLM gateway (#3)
add fallback options for height estimation
add NotebookLM-generated infographics
add additional layout options to blueprint
add LLM gateway to support multiple providers
</commit_message>
<xml_diff>
--- a/samples/layout_blueprint.pptx
+++ b/samples/layout_blueprint.pptx
@@ -27,6 +27,12 @@
     <p:sldId id="275" r:id="rId26"/>
     <p:sldId id="276" r:id="rId27"/>
     <p:sldId id="277" r:id="rId28"/>
+    <p:sldId id="278" r:id="rId29"/>
+    <p:sldId id="279" r:id="rId30"/>
+    <p:sldId id="280" r:id="rId31"/>
+    <p:sldId id="281" r:id="rId32"/>
+    <p:sldId id="282" r:id="rId33"/>
+    <p:sldId id="283" r:id="rId34"/>
   </p:sldIdLst>
   <p:sldSz cx="12191695" cy="6858000" type="screen4x3"/>
   <p:notesSz cx="6858000" cy="9144000"/>
@@ -11102,6 +11108,2494 @@
                 <a:latin typeface="Aptos"/>
               </a:rPr>
               <a:t>footer</a:t>
+            </a:r>
+          </a:p>
+        </p:txBody>
+      </p:sp>
+    </p:spTree>
+  </p:cSld>
+  <p:clrMapOvr>
+    <a:masterClrMapping/>
+  </p:clrMapOvr>
+</p:sld>
+</file>
+
+<file path=ppt/slides/slide23.xml><?xml version="1.0" encoding="utf-8"?>
+<p:sld xmlns:a="http://schemas.openxmlformats.org/drawingml/2006/main" xmlns:p="http://schemas.openxmlformats.org/presentationml/2006/main" xmlns:r="http://schemas.openxmlformats.org/officeDocument/2006/relationships">
+  <p:cSld>
+    <p:bg>
+      <p:bgPr>
+        <a:solidFill>
+          <a:srgbClr val="F7F4EC"/>
+        </a:solidFill>
+        <a:effectLst/>
+      </p:bgPr>
+    </p:bg>
+    <p:spTree>
+      <p:nvGrpSpPr>
+        <p:cNvPr id="1" name=""/>
+        <p:cNvGrpSpPr/>
+        <p:nvPr/>
+      </p:nvGrpSpPr>
+      <p:grpSpPr/>
+      <p:sp>
+        <p:nvSpPr>
+          <p:cNvPr id="2" name="Rounded Rectangle 1"/>
+          <p:cNvSpPr/>
+          <p:nvPr/>
+        </p:nvSpPr>
+        <p:spPr>
+          <a:xfrm>
+            <a:off x="1033271" y="2590769"/>
+            <a:ext cx="8193024" cy="592836"/>
+          </a:xfrm>
+          <a:prstGeom prst="roundRect">
+            <a:avLst/>
+          </a:prstGeom>
+          <a:solidFill>
+            <a:srgbClr val="DDD2B0"/>
+          </a:solidFill>
+          <a:ln w="19050">
+            <a:solidFill>
+              <a:srgbClr val="6E7F79"/>
+            </a:solidFill>
+          </a:ln>
+        </p:spPr>
+        <p:style>
+          <a:lnRef idx="1">
+            <a:schemeClr val="accent1"/>
+          </a:lnRef>
+          <a:fillRef idx="3">
+            <a:schemeClr val="accent1"/>
+          </a:fillRef>
+          <a:effectRef idx="2">
+            <a:schemeClr val="accent1"/>
+          </a:effectRef>
+          <a:fontRef idx="minor">
+            <a:schemeClr val="lt1"/>
+          </a:fontRef>
+        </p:style>
+        <p:txBody>
+          <a:bodyPr rtlCol="0" anchor="ctr" wrap="square"/>
+          <a:lstStyle/>
+          <a:p>
+            <a:pPr algn="ctr"/>
+            <a:r>
+              <a:rPr sz="2200" b="1">
+                <a:solidFill>
+                  <a:srgbClr val="20302C"/>
+                </a:solidFill>
+                <a:latin typeface="Aptos"/>
+              </a:rPr>
+              <a:t>title</a:t>
+            </a:r>
+          </a:p>
+        </p:txBody>
+      </p:sp>
+      <p:sp>
+        <p:nvSpPr>
+          <p:cNvPr id="3" name="Rectangle 2"/>
+          <p:cNvSpPr/>
+          <p:nvPr/>
+        </p:nvSpPr>
+        <p:spPr>
+          <a:xfrm>
+            <a:off x="1033271" y="3256757"/>
+            <a:ext cx="8193024" cy="457200"/>
+          </a:xfrm>
+          <a:prstGeom prst="rect">
+            <a:avLst/>
+          </a:prstGeom>
+          <a:solidFill>
+            <a:srgbClr val="E8E1CD"/>
+          </a:solidFill>
+          <a:ln w="19050">
+            <a:solidFill>
+              <a:srgbClr val="6E7F79"/>
+            </a:solidFill>
+          </a:ln>
+        </p:spPr>
+        <p:style>
+          <a:lnRef idx="1">
+            <a:schemeClr val="accent1"/>
+          </a:lnRef>
+          <a:fillRef idx="3">
+            <a:schemeClr val="accent1"/>
+          </a:fillRef>
+          <a:effectRef idx="2">
+            <a:schemeClr val="accent1"/>
+          </a:effectRef>
+          <a:fontRef idx="minor">
+            <a:schemeClr val="lt1"/>
+          </a:fontRef>
+        </p:style>
+        <p:txBody>
+          <a:bodyPr rtlCol="0" anchor="ctr" wrap="square"/>
+          <a:lstStyle/>
+          <a:p>
+            <a:pPr algn="ctr"/>
+            <a:r>
+              <a:rPr sz="1600" b="0">
+                <a:solidFill>
+                  <a:srgbClr val="20302C"/>
+                </a:solidFill>
+                <a:latin typeface="Aptos"/>
+              </a:rPr>
+              <a:t>key_message</a:t>
+            </a:r>
+          </a:p>
+        </p:txBody>
+      </p:sp>
+      <p:sp>
+        <p:nvSpPr>
+          <p:cNvPr id="4" name="Rectangle 3"/>
+          <p:cNvSpPr/>
+          <p:nvPr/>
+        </p:nvSpPr>
+        <p:spPr>
+          <a:xfrm>
+            <a:off x="822960" y="1828800"/>
+            <a:ext cx="1371600" cy="45720"/>
+          </a:xfrm>
+          <a:prstGeom prst="rect">
+            <a:avLst/>
+          </a:prstGeom>
+          <a:solidFill>
+            <a:srgbClr val="B8643C"/>
+          </a:solidFill>
+          <a:ln>
+            <a:noFill/>
+          </a:ln>
+        </p:spPr>
+        <p:style>
+          <a:lnRef idx="1">
+            <a:schemeClr val="accent1"/>
+          </a:lnRef>
+          <a:fillRef idx="3">
+            <a:schemeClr val="accent1"/>
+          </a:fillRef>
+          <a:effectRef idx="2">
+            <a:schemeClr val="accent1"/>
+          </a:effectRef>
+          <a:fontRef idx="minor">
+            <a:schemeClr val="lt1"/>
+          </a:fontRef>
+        </p:style>
+        <p:txBody>
+          <a:bodyPr rtlCol="0" anchor="ctr"/>
+          <a:lstStyle/>
+          <a:p>
+            <a:pPr algn="ctr"/>
+          </a:p>
+        </p:txBody>
+      </p:sp>
+      <p:sp>
+        <p:nvSpPr>
+          <p:cNvPr id="5" name="Rounded Rectangle 4"/>
+          <p:cNvSpPr/>
+          <p:nvPr/>
+        </p:nvSpPr>
+        <p:spPr>
+          <a:xfrm>
+            <a:off x="822960" y="1664208"/>
+            <a:ext cx="1115568" cy="256032"/>
+          </a:xfrm>
+          <a:prstGeom prst="roundRect">
+            <a:avLst/>
+          </a:prstGeom>
+          <a:solidFill>
+            <a:srgbClr val="E8E1CD"/>
+          </a:solidFill>
+          <a:ln w="19050">
+            <a:solidFill>
+              <a:srgbClr val="6E7F79"/>
+            </a:solidFill>
+          </a:ln>
+        </p:spPr>
+        <p:style>
+          <a:lnRef idx="1">
+            <a:schemeClr val="accent1"/>
+          </a:lnRef>
+          <a:fillRef idx="3">
+            <a:schemeClr val="accent1"/>
+          </a:fillRef>
+          <a:effectRef idx="2">
+            <a:schemeClr val="accent1"/>
+          </a:effectRef>
+          <a:fontRef idx="minor">
+            <a:schemeClr val="lt1"/>
+          </a:fontRef>
+        </p:style>
+        <p:txBody>
+          <a:bodyPr rtlCol="0" anchor="ctr" wrap="square"/>
+          <a:lstStyle/>
+          <a:p>
+            <a:pPr algn="ctr"/>
+            <a:r>
+              <a:rPr sz="1000" b="0">
+                <a:solidFill>
+                  <a:srgbClr val="20302C"/>
+                </a:solidFill>
+                <a:latin typeface="Aptos"/>
+              </a:rPr>
+              <a:t>accent</a:t>
+            </a:r>
+          </a:p>
+        </p:txBody>
+      </p:sp>
+      <p:sp>
+        <p:nvSpPr>
+          <p:cNvPr id="6" name="Oval 5"/>
+          <p:cNvSpPr/>
+          <p:nvPr/>
+        </p:nvSpPr>
+        <p:spPr>
+          <a:xfrm>
+            <a:off x="10268712" y="411480"/>
+            <a:ext cx="1463040" cy="1463040"/>
+          </a:xfrm>
+          <a:prstGeom prst="ellipse">
+            <a:avLst/>
+          </a:prstGeom>
+          <a:solidFill>
+            <a:srgbClr val="C7DCCF"/>
+          </a:solidFill>
+          <a:ln w="19050">
+            <a:solidFill>
+              <a:srgbClr val="6E7F79"/>
+            </a:solidFill>
+          </a:ln>
+        </p:spPr>
+        <p:style>
+          <a:lnRef idx="1">
+            <a:schemeClr val="accent1"/>
+          </a:lnRef>
+          <a:fillRef idx="3">
+            <a:schemeClr val="accent1"/>
+          </a:fillRef>
+          <a:effectRef idx="2">
+            <a:schemeClr val="accent1"/>
+          </a:effectRef>
+          <a:fontRef idx="minor">
+            <a:schemeClr val="lt1"/>
+          </a:fontRef>
+        </p:style>
+        <p:txBody>
+          <a:bodyPr rtlCol="0" anchor="ctr" wrap="square"/>
+          <a:lstStyle/>
+          <a:p>
+            <a:pPr algn="ctr"/>
+            <a:r>
+              <a:rPr sz="1600" b="1">
+                <a:solidFill>
+                  <a:srgbClr val="20302C"/>
+                </a:solidFill>
+                <a:latin typeface="Aptos"/>
+              </a:rPr>
+              <a:t>icon</a:t>
+            </a:r>
+          </a:p>
+        </p:txBody>
+      </p:sp>
+      <p:sp>
+        <p:nvSpPr>
+          <p:cNvPr id="7" name="Rectangle 6"/>
+          <p:cNvSpPr/>
+          <p:nvPr/>
+        </p:nvSpPr>
+        <p:spPr>
+          <a:xfrm>
+            <a:off x="822960" y="5650992"/>
+            <a:ext cx="10545775" cy="640080"/>
+          </a:xfrm>
+          <a:prstGeom prst="rect">
+            <a:avLst/>
+          </a:prstGeom>
+          <a:solidFill>
+            <a:srgbClr val="F0E8D8"/>
+          </a:solidFill>
+          <a:ln w="19050">
+            <a:solidFill>
+              <a:srgbClr val="6E7F79"/>
+            </a:solidFill>
+          </a:ln>
+        </p:spPr>
+        <p:style>
+          <a:lnRef idx="1">
+            <a:schemeClr val="accent1"/>
+          </a:lnRef>
+          <a:fillRef idx="3">
+            <a:schemeClr val="accent1"/>
+          </a:fillRef>
+          <a:effectRef idx="2">
+            <a:schemeClr val="accent1"/>
+          </a:effectRef>
+          <a:fontRef idx="minor">
+            <a:schemeClr val="lt1"/>
+          </a:fontRef>
+        </p:style>
+        <p:txBody>
+          <a:bodyPr rtlCol="0" anchor="ctr" wrap="square"/>
+          <a:lstStyle/>
+          <a:p>
+            <a:pPr algn="ctr"/>
+            <a:r>
+              <a:rPr sz="1100" b="0">
+                <a:solidFill>
+                  <a:srgbClr val="20302C"/>
+                </a:solidFill>
+                <a:latin typeface="Aptos"/>
+              </a:rPr>
+              <a:t>notes</a:t>
+            </a:r>
+          </a:p>
+        </p:txBody>
+      </p:sp>
+      <p:sp>
+        <p:nvSpPr>
+          <p:cNvPr id="8" name="Rectangle 7"/>
+          <p:cNvSpPr/>
+          <p:nvPr/>
+        </p:nvSpPr>
+        <p:spPr>
+          <a:xfrm>
+            <a:off x="822960" y="3787109"/>
+            <a:ext cx="8622792" cy="1004346"/>
+          </a:xfrm>
+          <a:prstGeom prst="rect">
+            <a:avLst/>
+          </a:prstGeom>
+          <a:solidFill>
+            <a:srgbClr val="F2EAD6"/>
+          </a:solidFill>
+          <a:ln w="19050">
+            <a:solidFill>
+              <a:srgbClr val="6E7F79"/>
+            </a:solidFill>
+          </a:ln>
+        </p:spPr>
+        <p:style>
+          <a:lnRef idx="1">
+            <a:schemeClr val="accent1"/>
+          </a:lnRef>
+          <a:fillRef idx="3">
+            <a:schemeClr val="accent1"/>
+          </a:fillRef>
+          <a:effectRef idx="2">
+            <a:schemeClr val="accent1"/>
+          </a:effectRef>
+          <a:fontRef idx="minor">
+            <a:schemeClr val="lt1"/>
+          </a:fontRef>
+        </p:style>
+        <p:txBody>
+          <a:bodyPr rtlCol="0" anchor="ctr" wrap="square"/>
+          <a:lstStyle/>
+          <a:p>
+            <a:pPr algn="ctr"/>
+            <a:r>
+              <a:rPr sz="1800" b="0">
+                <a:solidFill>
+                  <a:srgbClr val="20302C"/>
+                </a:solidFill>
+                <a:latin typeface="Aptos"/>
+              </a:rPr>
+              <a:t>content</a:t>
+            </a:r>
+          </a:p>
+        </p:txBody>
+      </p:sp>
+      <p:sp>
+        <p:nvSpPr>
+          <p:cNvPr id="9" name="Rectangle 8"/>
+          <p:cNvSpPr/>
+          <p:nvPr/>
+        </p:nvSpPr>
+        <p:spPr>
+          <a:xfrm>
+            <a:off x="822960" y="4901184"/>
+            <a:ext cx="8622792" cy="548639"/>
+          </a:xfrm>
+          <a:prstGeom prst="rect">
+            <a:avLst/>
+          </a:prstGeom>
+          <a:solidFill>
+            <a:srgbClr val="E8E1CD"/>
+          </a:solidFill>
+          <a:ln w="19050">
+            <a:solidFill>
+              <a:srgbClr val="6E7F79"/>
+            </a:solidFill>
+          </a:ln>
+        </p:spPr>
+        <p:style>
+          <a:lnRef idx="1">
+            <a:schemeClr val="accent1"/>
+          </a:lnRef>
+          <a:fillRef idx="3">
+            <a:schemeClr val="accent1"/>
+          </a:fillRef>
+          <a:effectRef idx="2">
+            <a:schemeClr val="accent1"/>
+          </a:effectRef>
+          <a:fontRef idx="minor">
+            <a:schemeClr val="lt1"/>
+          </a:fontRef>
+        </p:style>
+        <p:txBody>
+          <a:bodyPr rtlCol="0" anchor="ctr" wrap="square"/>
+          <a:lstStyle/>
+          <a:p>
+            <a:pPr algn="ctr"/>
+            <a:r>
+              <a:rPr sz="1300" b="0">
+                <a:solidFill>
+                  <a:srgbClr val="20302C"/>
+                </a:solidFill>
+                <a:latin typeface="Aptos"/>
+              </a:rPr>
+              <a:t>footer</a:t>
+            </a:r>
+          </a:p>
+        </p:txBody>
+      </p:sp>
+    </p:spTree>
+  </p:cSld>
+  <p:clrMapOvr>
+    <a:masterClrMapping/>
+  </p:clrMapOvr>
+</p:sld>
+</file>
+
+<file path=ppt/slides/slide24.xml><?xml version="1.0" encoding="utf-8"?>
+<p:sld xmlns:a="http://schemas.openxmlformats.org/drawingml/2006/main" xmlns:p="http://schemas.openxmlformats.org/presentationml/2006/main" xmlns:r="http://schemas.openxmlformats.org/officeDocument/2006/relationships">
+  <p:cSld>
+    <p:bg>
+      <p:bgPr>
+        <a:solidFill>
+          <a:srgbClr val="EFF5F1"/>
+        </a:solidFill>
+        <a:effectLst/>
+      </p:bgPr>
+    </p:bg>
+    <p:spTree>
+      <p:nvGrpSpPr>
+        <p:cNvPr id="1" name=""/>
+        <p:cNvGrpSpPr/>
+        <p:nvPr/>
+      </p:nvGrpSpPr>
+      <p:grpSpPr/>
+      <p:sp>
+        <p:nvSpPr>
+          <p:cNvPr id="2" name="Rounded Rectangle 1"/>
+          <p:cNvSpPr/>
+          <p:nvPr/>
+        </p:nvSpPr>
+        <p:spPr>
+          <a:xfrm>
+            <a:off x="1033271" y="2039112"/>
+            <a:ext cx="7845552" cy="548640"/>
+          </a:xfrm>
+          <a:prstGeom prst="roundRect">
+            <a:avLst/>
+          </a:prstGeom>
+          <a:solidFill>
+            <a:srgbClr val="CFE0D2"/>
+          </a:solidFill>
+          <a:ln w="19050">
+            <a:solidFill>
+              <a:srgbClr val="6E7F79"/>
+            </a:solidFill>
+          </a:ln>
+        </p:spPr>
+        <p:style>
+          <a:lnRef idx="1">
+            <a:schemeClr val="accent1"/>
+          </a:lnRef>
+          <a:fillRef idx="3">
+            <a:schemeClr val="accent1"/>
+          </a:fillRef>
+          <a:effectRef idx="2">
+            <a:schemeClr val="accent1"/>
+          </a:effectRef>
+          <a:fontRef idx="minor">
+            <a:schemeClr val="lt1"/>
+          </a:fontRef>
+        </p:style>
+        <p:txBody>
+          <a:bodyPr rtlCol="0" anchor="ctr" wrap="square"/>
+          <a:lstStyle/>
+          <a:p>
+            <a:pPr algn="ctr"/>
+            <a:r>
+              <a:rPr sz="2200" b="1">
+                <a:solidFill>
+                  <a:srgbClr val="20302C"/>
+                </a:solidFill>
+                <a:latin typeface="Aptos"/>
+              </a:rPr>
+              <a:t>title</a:t>
+            </a:r>
+          </a:p>
+        </p:txBody>
+      </p:sp>
+      <p:sp>
+        <p:nvSpPr>
+          <p:cNvPr id="3" name="Rectangle 2"/>
+          <p:cNvSpPr/>
+          <p:nvPr/>
+        </p:nvSpPr>
+        <p:spPr>
+          <a:xfrm>
+            <a:off x="1033271" y="2660904"/>
+            <a:ext cx="7845552" cy="457200"/>
+          </a:xfrm>
+          <a:prstGeom prst="rect">
+            <a:avLst/>
+          </a:prstGeom>
+          <a:solidFill>
+            <a:srgbClr val="E0ECE4"/>
+          </a:solidFill>
+          <a:ln w="19050">
+            <a:solidFill>
+              <a:srgbClr val="6E7F79"/>
+            </a:solidFill>
+          </a:ln>
+        </p:spPr>
+        <p:style>
+          <a:lnRef idx="1">
+            <a:schemeClr val="accent1"/>
+          </a:lnRef>
+          <a:fillRef idx="3">
+            <a:schemeClr val="accent1"/>
+          </a:fillRef>
+          <a:effectRef idx="2">
+            <a:schemeClr val="accent1"/>
+          </a:effectRef>
+          <a:fontRef idx="minor">
+            <a:schemeClr val="lt1"/>
+          </a:fontRef>
+        </p:style>
+        <p:txBody>
+          <a:bodyPr rtlCol="0" anchor="ctr" wrap="square"/>
+          <a:lstStyle/>
+          <a:p>
+            <a:pPr algn="ctr"/>
+            <a:r>
+              <a:rPr sz="1600" b="0">
+                <a:solidFill>
+                  <a:srgbClr val="20302C"/>
+                </a:solidFill>
+                <a:latin typeface="Aptos"/>
+              </a:rPr>
+              <a:t>key_message</a:t>
+            </a:r>
+          </a:p>
+        </p:txBody>
+      </p:sp>
+      <p:sp>
+        <p:nvSpPr>
+          <p:cNvPr id="4" name="Rectangle 3"/>
+          <p:cNvSpPr/>
+          <p:nvPr/>
+        </p:nvSpPr>
+        <p:spPr>
+          <a:xfrm>
+            <a:off x="822960" y="1828800"/>
+            <a:ext cx="1371600" cy="45720"/>
+          </a:xfrm>
+          <a:prstGeom prst="rect">
+            <a:avLst/>
+          </a:prstGeom>
+          <a:solidFill>
+            <a:srgbClr val="B8643C"/>
+          </a:solidFill>
+          <a:ln>
+            <a:noFill/>
+          </a:ln>
+        </p:spPr>
+        <p:style>
+          <a:lnRef idx="1">
+            <a:schemeClr val="accent1"/>
+          </a:lnRef>
+          <a:fillRef idx="3">
+            <a:schemeClr val="accent1"/>
+          </a:fillRef>
+          <a:effectRef idx="2">
+            <a:schemeClr val="accent1"/>
+          </a:effectRef>
+          <a:fontRef idx="minor">
+            <a:schemeClr val="lt1"/>
+          </a:fontRef>
+        </p:style>
+        <p:txBody>
+          <a:bodyPr rtlCol="0" anchor="ctr"/>
+          <a:lstStyle/>
+          <a:p>
+            <a:pPr algn="ctr"/>
+          </a:p>
+        </p:txBody>
+      </p:sp>
+      <p:sp>
+        <p:nvSpPr>
+          <p:cNvPr id="5" name="Rounded Rectangle 4"/>
+          <p:cNvSpPr/>
+          <p:nvPr/>
+        </p:nvSpPr>
+        <p:spPr>
+          <a:xfrm>
+            <a:off x="822960" y="1664208"/>
+            <a:ext cx="1115568" cy="256032"/>
+          </a:xfrm>
+          <a:prstGeom prst="roundRect">
+            <a:avLst/>
+          </a:prstGeom>
+          <a:solidFill>
+            <a:srgbClr val="E8E1CD"/>
+          </a:solidFill>
+          <a:ln w="19050">
+            <a:solidFill>
+              <a:srgbClr val="6E7F79"/>
+            </a:solidFill>
+          </a:ln>
+        </p:spPr>
+        <p:style>
+          <a:lnRef idx="1">
+            <a:schemeClr val="accent1"/>
+          </a:lnRef>
+          <a:fillRef idx="3">
+            <a:schemeClr val="accent1"/>
+          </a:fillRef>
+          <a:effectRef idx="2">
+            <a:schemeClr val="accent1"/>
+          </a:effectRef>
+          <a:fontRef idx="minor">
+            <a:schemeClr val="lt1"/>
+          </a:fontRef>
+        </p:style>
+        <p:txBody>
+          <a:bodyPr rtlCol="0" anchor="ctr" wrap="square"/>
+          <a:lstStyle/>
+          <a:p>
+            <a:pPr algn="ctr"/>
+            <a:r>
+              <a:rPr sz="1000" b="0">
+                <a:solidFill>
+                  <a:srgbClr val="20302C"/>
+                </a:solidFill>
+                <a:latin typeface="Aptos"/>
+              </a:rPr>
+              <a:t>accent</a:t>
+            </a:r>
+          </a:p>
+        </p:txBody>
+      </p:sp>
+      <p:sp>
+        <p:nvSpPr>
+          <p:cNvPr id="6" name="Rectangle 5"/>
+          <p:cNvSpPr/>
+          <p:nvPr/>
+        </p:nvSpPr>
+        <p:spPr>
+          <a:xfrm>
+            <a:off x="822960" y="5650992"/>
+            <a:ext cx="10543032" cy="640080"/>
+          </a:xfrm>
+          <a:prstGeom prst="rect">
+            <a:avLst/>
+          </a:prstGeom>
+          <a:solidFill>
+            <a:srgbClr val="E8F0EA"/>
+          </a:solidFill>
+          <a:ln w="19050">
+            <a:solidFill>
+              <a:srgbClr val="6E7F79"/>
+            </a:solidFill>
+          </a:ln>
+        </p:spPr>
+        <p:style>
+          <a:lnRef idx="1">
+            <a:schemeClr val="accent1"/>
+          </a:lnRef>
+          <a:fillRef idx="3">
+            <a:schemeClr val="accent1"/>
+          </a:fillRef>
+          <a:effectRef idx="2">
+            <a:schemeClr val="accent1"/>
+          </a:effectRef>
+          <a:fontRef idx="minor">
+            <a:schemeClr val="lt1"/>
+          </a:fontRef>
+        </p:style>
+        <p:txBody>
+          <a:bodyPr rtlCol="0" anchor="ctr" wrap="square"/>
+          <a:lstStyle/>
+          <a:p>
+            <a:pPr algn="ctr"/>
+            <a:r>
+              <a:rPr sz="1100" b="0">
+                <a:solidFill>
+                  <a:srgbClr val="20302C"/>
+                </a:solidFill>
+                <a:latin typeface="Aptos"/>
+              </a:rPr>
+              <a:t>notes</a:t>
+            </a:r>
+          </a:p>
+        </p:txBody>
+      </p:sp>
+      <p:sp>
+        <p:nvSpPr>
+          <p:cNvPr id="7" name="Oval 6"/>
+          <p:cNvSpPr/>
+          <p:nvPr/>
+        </p:nvSpPr>
+        <p:spPr>
+          <a:xfrm>
+            <a:off x="10268712" y="411480"/>
+            <a:ext cx="1463040" cy="1463040"/>
+          </a:xfrm>
+          <a:prstGeom prst="ellipse">
+            <a:avLst/>
+          </a:prstGeom>
+          <a:solidFill>
+            <a:srgbClr val="C7DCCF"/>
+          </a:solidFill>
+          <a:ln w="19050">
+            <a:solidFill>
+              <a:srgbClr val="6E7F79"/>
+            </a:solidFill>
+          </a:ln>
+        </p:spPr>
+        <p:style>
+          <a:lnRef idx="1">
+            <a:schemeClr val="accent1"/>
+          </a:lnRef>
+          <a:fillRef idx="3">
+            <a:schemeClr val="accent1"/>
+          </a:fillRef>
+          <a:effectRef idx="2">
+            <a:schemeClr val="accent1"/>
+          </a:effectRef>
+          <a:fontRef idx="minor">
+            <a:schemeClr val="lt1"/>
+          </a:fontRef>
+        </p:style>
+        <p:txBody>
+          <a:bodyPr rtlCol="0" anchor="ctr" wrap="square"/>
+          <a:lstStyle/>
+          <a:p>
+            <a:pPr algn="ctr"/>
+            <a:r>
+              <a:rPr sz="1600" b="1">
+                <a:solidFill>
+                  <a:srgbClr val="20302C"/>
+                </a:solidFill>
+                <a:latin typeface="Aptos"/>
+              </a:rPr>
+              <a:t>icon</a:t>
+            </a:r>
+          </a:p>
+        </p:txBody>
+      </p:sp>
+    </p:spTree>
+  </p:cSld>
+  <p:clrMapOvr>
+    <a:masterClrMapping/>
+  </p:clrMapOvr>
+</p:sld>
+</file>
+
+<file path=ppt/slides/slide25.xml><?xml version="1.0" encoding="utf-8"?>
+<p:sld xmlns:a="http://schemas.openxmlformats.org/drawingml/2006/main" xmlns:p="http://schemas.openxmlformats.org/presentationml/2006/main" xmlns:r="http://schemas.openxmlformats.org/officeDocument/2006/relationships">
+  <p:cSld>
+    <p:bg>
+      <p:bgPr>
+        <a:solidFill>
+          <a:srgbClr val="F7F4EC"/>
+        </a:solidFill>
+        <a:effectLst/>
+      </p:bgPr>
+    </p:bg>
+    <p:spTree>
+      <p:nvGrpSpPr>
+        <p:cNvPr id="1" name=""/>
+        <p:cNvGrpSpPr/>
+        <p:nvPr/>
+      </p:nvGrpSpPr>
+      <p:grpSpPr/>
+      <p:sp>
+        <p:nvSpPr>
+          <p:cNvPr id="2" name="Rounded Rectangle 1"/>
+          <p:cNvSpPr/>
+          <p:nvPr/>
+        </p:nvSpPr>
+        <p:spPr>
+          <a:xfrm>
+            <a:off x="914400" y="3657600"/>
+            <a:ext cx="10360152" cy="914400"/>
+          </a:xfrm>
+          <a:prstGeom prst="roundRect">
+            <a:avLst/>
+          </a:prstGeom>
+          <a:solidFill>
+            <a:srgbClr val="DDD2B0"/>
+          </a:solidFill>
+          <a:ln w="19050">
+            <a:solidFill>
+              <a:srgbClr val="6E7F79"/>
+            </a:solidFill>
+          </a:ln>
+        </p:spPr>
+        <p:style>
+          <a:lnRef idx="1">
+            <a:schemeClr val="accent1"/>
+          </a:lnRef>
+          <a:fillRef idx="3">
+            <a:schemeClr val="accent1"/>
+          </a:fillRef>
+          <a:effectRef idx="2">
+            <a:schemeClr val="accent1"/>
+          </a:effectRef>
+          <a:fontRef idx="minor">
+            <a:schemeClr val="lt1"/>
+          </a:fontRef>
+        </p:style>
+        <p:txBody>
+          <a:bodyPr rtlCol="0" anchor="ctr" wrap="square"/>
+          <a:lstStyle/>
+          <a:p>
+            <a:pPr algn="ctr"/>
+            <a:r>
+              <a:rPr sz="2200" b="1">
+                <a:solidFill>
+                  <a:srgbClr val="20302C"/>
+                </a:solidFill>
+                <a:latin typeface="Aptos"/>
+              </a:rPr>
+              <a:t>title</a:t>
+            </a:r>
+          </a:p>
+        </p:txBody>
+      </p:sp>
+      <p:sp>
+        <p:nvSpPr>
+          <p:cNvPr id="3" name="Rectangle 2"/>
+          <p:cNvSpPr/>
+          <p:nvPr/>
+        </p:nvSpPr>
+        <p:spPr>
+          <a:xfrm>
+            <a:off x="914400" y="4645152"/>
+            <a:ext cx="10360152" cy="457200"/>
+          </a:xfrm>
+          <a:prstGeom prst="rect">
+            <a:avLst/>
+          </a:prstGeom>
+          <a:solidFill>
+            <a:srgbClr val="E8E1CD"/>
+          </a:solidFill>
+          <a:ln w="19050">
+            <a:solidFill>
+              <a:srgbClr val="6E7F79"/>
+            </a:solidFill>
+          </a:ln>
+        </p:spPr>
+        <p:style>
+          <a:lnRef idx="1">
+            <a:schemeClr val="accent1"/>
+          </a:lnRef>
+          <a:fillRef idx="3">
+            <a:schemeClr val="accent1"/>
+          </a:fillRef>
+          <a:effectRef idx="2">
+            <a:schemeClr val="accent1"/>
+          </a:effectRef>
+          <a:fontRef idx="minor">
+            <a:schemeClr val="lt1"/>
+          </a:fontRef>
+        </p:style>
+        <p:txBody>
+          <a:bodyPr rtlCol="0" anchor="ctr" wrap="square"/>
+          <a:lstStyle/>
+          <a:p>
+            <a:pPr algn="ctr"/>
+            <a:r>
+              <a:rPr sz="1600" b="0">
+                <a:solidFill>
+                  <a:srgbClr val="20302C"/>
+                </a:solidFill>
+                <a:latin typeface="Aptos"/>
+              </a:rPr>
+              <a:t>key_message</a:t>
+            </a:r>
+          </a:p>
+        </p:txBody>
+      </p:sp>
+      <p:sp>
+        <p:nvSpPr>
+          <p:cNvPr id="4" name="Rounded Rectangle 3"/>
+          <p:cNvSpPr/>
+          <p:nvPr/>
+        </p:nvSpPr>
+        <p:spPr>
+          <a:xfrm>
+            <a:off x="8211312" y="5175504"/>
+            <a:ext cx="3337560" cy="1408176"/>
+          </a:xfrm>
+          <a:prstGeom prst="roundRect">
+            <a:avLst/>
+          </a:prstGeom>
+          <a:solidFill>
+            <a:srgbClr val="C7DCCF"/>
+          </a:solidFill>
+          <a:ln w="19050">
+            <a:solidFill>
+              <a:srgbClr val="6E7F79"/>
+            </a:solidFill>
+          </a:ln>
+        </p:spPr>
+        <p:style>
+          <a:lnRef idx="1">
+            <a:schemeClr val="accent1"/>
+          </a:lnRef>
+          <a:fillRef idx="3">
+            <a:schemeClr val="accent1"/>
+          </a:fillRef>
+          <a:effectRef idx="2">
+            <a:schemeClr val="accent1"/>
+          </a:effectRef>
+          <a:fontRef idx="minor">
+            <a:schemeClr val="lt1"/>
+          </a:fontRef>
+        </p:style>
+        <p:txBody>
+          <a:bodyPr rtlCol="0" anchor="ctr" wrap="square"/>
+          <a:lstStyle/>
+          <a:p>
+            <a:pPr algn="ctr"/>
+            <a:r>
+              <a:rPr sz="2200" b="1">
+                <a:solidFill>
+                  <a:srgbClr val="20302C"/>
+                </a:solidFill>
+                <a:latin typeface="Aptos"/>
+              </a:rPr>
+              <a:t>hero</a:t>
+            </a:r>
+          </a:p>
+        </p:txBody>
+      </p:sp>
+      <p:sp>
+        <p:nvSpPr>
+          <p:cNvPr id="5" name="Rectangle 4"/>
+          <p:cNvSpPr/>
+          <p:nvPr/>
+        </p:nvSpPr>
+        <p:spPr>
+          <a:xfrm>
+            <a:off x="640080" y="5650992"/>
+            <a:ext cx="10911535" cy="640080"/>
+          </a:xfrm>
+          <a:prstGeom prst="rect">
+            <a:avLst/>
+          </a:prstGeom>
+          <a:solidFill>
+            <a:srgbClr val="F0E8D8"/>
+          </a:solidFill>
+          <a:ln w="19050">
+            <a:solidFill>
+              <a:srgbClr val="6E7F79"/>
+            </a:solidFill>
+          </a:ln>
+        </p:spPr>
+        <p:style>
+          <a:lnRef idx="1">
+            <a:schemeClr val="accent1"/>
+          </a:lnRef>
+          <a:fillRef idx="3">
+            <a:schemeClr val="accent1"/>
+          </a:fillRef>
+          <a:effectRef idx="2">
+            <a:schemeClr val="accent1"/>
+          </a:effectRef>
+          <a:fontRef idx="minor">
+            <a:schemeClr val="lt1"/>
+          </a:fontRef>
+        </p:style>
+        <p:txBody>
+          <a:bodyPr rtlCol="0" anchor="ctr" wrap="square"/>
+          <a:lstStyle/>
+          <a:p>
+            <a:pPr algn="ctr"/>
+            <a:r>
+              <a:rPr sz="1100" b="0">
+                <a:solidFill>
+                  <a:srgbClr val="20302C"/>
+                </a:solidFill>
+                <a:latin typeface="Aptos"/>
+              </a:rPr>
+              <a:t>notes</a:t>
+            </a:r>
+          </a:p>
+        </p:txBody>
+      </p:sp>
+      <p:sp>
+        <p:nvSpPr>
+          <p:cNvPr id="6" name="Rectangle 5"/>
+          <p:cNvSpPr/>
+          <p:nvPr/>
+        </p:nvSpPr>
+        <p:spPr>
+          <a:xfrm>
+            <a:off x="640080" y="5175504"/>
+            <a:ext cx="10908792" cy="731520"/>
+          </a:xfrm>
+          <a:prstGeom prst="rect">
+            <a:avLst/>
+          </a:prstGeom>
+          <a:solidFill>
+            <a:srgbClr val="F2EAD6"/>
+          </a:solidFill>
+          <a:ln w="19050">
+            <a:solidFill>
+              <a:srgbClr val="6E7F79"/>
+            </a:solidFill>
+          </a:ln>
+        </p:spPr>
+        <p:style>
+          <a:lnRef idx="1">
+            <a:schemeClr val="accent1"/>
+          </a:lnRef>
+          <a:fillRef idx="3">
+            <a:schemeClr val="accent1"/>
+          </a:fillRef>
+          <a:effectRef idx="2">
+            <a:schemeClr val="accent1"/>
+          </a:effectRef>
+          <a:fontRef idx="minor">
+            <a:schemeClr val="lt1"/>
+          </a:fontRef>
+        </p:style>
+        <p:txBody>
+          <a:bodyPr rtlCol="0" anchor="ctr" wrap="square"/>
+          <a:lstStyle/>
+          <a:p>
+            <a:pPr algn="ctr"/>
+            <a:r>
+              <a:rPr sz="1800" b="0">
+                <a:solidFill>
+                  <a:srgbClr val="20302C"/>
+                </a:solidFill>
+                <a:latin typeface="Aptos"/>
+              </a:rPr>
+              <a:t>content</a:t>
+            </a:r>
+          </a:p>
+        </p:txBody>
+      </p:sp>
+    </p:spTree>
+  </p:cSld>
+  <p:clrMapOvr>
+    <a:masterClrMapping/>
+  </p:clrMapOvr>
+</p:sld>
+</file>
+
+<file path=ppt/slides/slide26.xml><?xml version="1.0" encoding="utf-8"?>
+<p:sld xmlns:a="http://schemas.openxmlformats.org/drawingml/2006/main" xmlns:p="http://schemas.openxmlformats.org/presentationml/2006/main" xmlns:r="http://schemas.openxmlformats.org/officeDocument/2006/relationships">
+  <p:cSld>
+    <p:bg>
+      <p:bgPr>
+        <a:solidFill>
+          <a:srgbClr val="EFF5F1"/>
+        </a:solidFill>
+        <a:effectLst/>
+      </p:bgPr>
+    </p:bg>
+    <p:spTree>
+      <p:nvGrpSpPr>
+        <p:cNvPr id="1" name=""/>
+        <p:cNvGrpSpPr/>
+        <p:nvPr/>
+      </p:nvGrpSpPr>
+      <p:grpSpPr/>
+      <p:sp>
+        <p:nvSpPr>
+          <p:cNvPr id="2" name="Rounded Rectangle 1"/>
+          <p:cNvSpPr/>
+          <p:nvPr/>
+        </p:nvSpPr>
+        <p:spPr>
+          <a:xfrm>
+            <a:off x="813816" y="3657600"/>
+            <a:ext cx="6821424" cy="914400"/>
+          </a:xfrm>
+          <a:prstGeom prst="roundRect">
+            <a:avLst/>
+          </a:prstGeom>
+          <a:solidFill>
+            <a:srgbClr val="CFE0D2"/>
+          </a:solidFill>
+          <a:ln w="19050">
+            <a:solidFill>
+              <a:srgbClr val="6E7F79"/>
+            </a:solidFill>
+          </a:ln>
+        </p:spPr>
+        <p:style>
+          <a:lnRef idx="1">
+            <a:schemeClr val="accent1"/>
+          </a:lnRef>
+          <a:fillRef idx="3">
+            <a:schemeClr val="accent1"/>
+          </a:fillRef>
+          <a:effectRef idx="2">
+            <a:schemeClr val="accent1"/>
+          </a:effectRef>
+          <a:fontRef idx="minor">
+            <a:schemeClr val="lt1"/>
+          </a:fontRef>
+        </p:style>
+        <p:txBody>
+          <a:bodyPr rtlCol="0" anchor="ctr" wrap="square"/>
+          <a:lstStyle/>
+          <a:p>
+            <a:pPr algn="ctr"/>
+            <a:r>
+              <a:rPr sz="2200" b="1">
+                <a:solidFill>
+                  <a:srgbClr val="20302C"/>
+                </a:solidFill>
+                <a:latin typeface="Aptos"/>
+              </a:rPr>
+              <a:t>title</a:t>
+            </a:r>
+          </a:p>
+        </p:txBody>
+      </p:sp>
+      <p:sp>
+        <p:nvSpPr>
+          <p:cNvPr id="3" name="Rectangle 2"/>
+          <p:cNvSpPr/>
+          <p:nvPr/>
+        </p:nvSpPr>
+        <p:spPr>
+          <a:xfrm>
+            <a:off x="813816" y="4645152"/>
+            <a:ext cx="6821424" cy="457200"/>
+          </a:xfrm>
+          <a:prstGeom prst="rect">
+            <a:avLst/>
+          </a:prstGeom>
+          <a:solidFill>
+            <a:srgbClr val="E0ECE4"/>
+          </a:solidFill>
+          <a:ln w="19050">
+            <a:solidFill>
+              <a:srgbClr val="6E7F79"/>
+            </a:solidFill>
+          </a:ln>
+        </p:spPr>
+        <p:style>
+          <a:lnRef idx="1">
+            <a:schemeClr val="accent1"/>
+          </a:lnRef>
+          <a:fillRef idx="3">
+            <a:schemeClr val="accent1"/>
+          </a:fillRef>
+          <a:effectRef idx="2">
+            <a:schemeClr val="accent1"/>
+          </a:effectRef>
+          <a:fontRef idx="minor">
+            <a:schemeClr val="lt1"/>
+          </a:fontRef>
+        </p:style>
+        <p:txBody>
+          <a:bodyPr rtlCol="0" anchor="ctr" wrap="square"/>
+          <a:lstStyle/>
+          <a:p>
+            <a:pPr algn="ctr"/>
+            <a:r>
+              <a:rPr sz="1600" b="0">
+                <a:solidFill>
+                  <a:srgbClr val="20302C"/>
+                </a:solidFill>
+                <a:latin typeface="Aptos"/>
+              </a:rPr>
+              <a:t>key_message</a:t>
+            </a:r>
+          </a:p>
+        </p:txBody>
+      </p:sp>
+      <p:sp>
+        <p:nvSpPr>
+          <p:cNvPr id="4" name="Rectangle 3"/>
+          <p:cNvSpPr/>
+          <p:nvPr/>
+        </p:nvSpPr>
+        <p:spPr>
+          <a:xfrm>
+            <a:off x="640080" y="5650992"/>
+            <a:ext cx="10908792" cy="640080"/>
+          </a:xfrm>
+          <a:prstGeom prst="rect">
+            <a:avLst/>
+          </a:prstGeom>
+          <a:solidFill>
+            <a:srgbClr val="E8F0EA"/>
+          </a:solidFill>
+          <a:ln w="19050">
+            <a:solidFill>
+              <a:srgbClr val="6E7F79"/>
+            </a:solidFill>
+          </a:ln>
+        </p:spPr>
+        <p:style>
+          <a:lnRef idx="1">
+            <a:schemeClr val="accent1"/>
+          </a:lnRef>
+          <a:fillRef idx="3">
+            <a:schemeClr val="accent1"/>
+          </a:fillRef>
+          <a:effectRef idx="2">
+            <a:schemeClr val="accent1"/>
+          </a:effectRef>
+          <a:fontRef idx="minor">
+            <a:schemeClr val="lt1"/>
+          </a:fontRef>
+        </p:style>
+        <p:txBody>
+          <a:bodyPr rtlCol="0" anchor="ctr" wrap="square"/>
+          <a:lstStyle/>
+          <a:p>
+            <a:pPr algn="ctr"/>
+            <a:r>
+              <a:rPr sz="1100" b="0">
+                <a:solidFill>
+                  <a:srgbClr val="20302C"/>
+                </a:solidFill>
+                <a:latin typeface="Aptos"/>
+              </a:rPr>
+              <a:t>notes</a:t>
+            </a:r>
+          </a:p>
+        </p:txBody>
+      </p:sp>
+    </p:spTree>
+  </p:cSld>
+  <p:clrMapOvr>
+    <a:masterClrMapping/>
+  </p:clrMapOvr>
+</p:sld>
+</file>
+
+<file path=ppt/slides/slide27.xml><?xml version="1.0" encoding="utf-8"?>
+<p:sld xmlns:a="http://schemas.openxmlformats.org/drawingml/2006/main" xmlns:p="http://schemas.openxmlformats.org/presentationml/2006/main" xmlns:r="http://schemas.openxmlformats.org/officeDocument/2006/relationships">
+  <p:cSld>
+    <p:bg>
+      <p:bgPr>
+        <a:solidFill>
+          <a:srgbClr val="F7F4EC"/>
+        </a:solidFill>
+        <a:effectLst/>
+      </p:bgPr>
+    </p:bg>
+    <p:spTree>
+      <p:nvGrpSpPr>
+        <p:cNvPr id="1" name=""/>
+        <p:cNvGrpSpPr/>
+        <p:nvPr/>
+      </p:nvGrpSpPr>
+      <p:grpSpPr/>
+      <p:sp>
+        <p:nvSpPr>
+          <p:cNvPr id="2" name="Rounded Rectangle 1"/>
+          <p:cNvSpPr/>
+          <p:nvPr/>
+        </p:nvSpPr>
+        <p:spPr>
+          <a:xfrm>
+            <a:off x="685800" y="457200"/>
+            <a:ext cx="8887968" cy="592836"/>
+          </a:xfrm>
+          <a:prstGeom prst="roundRect">
+            <a:avLst/>
+          </a:prstGeom>
+          <a:solidFill>
+            <a:srgbClr val="DDD2B0"/>
+          </a:solidFill>
+          <a:ln w="19050">
+            <a:solidFill>
+              <a:srgbClr val="6E7F79"/>
+            </a:solidFill>
+          </a:ln>
+        </p:spPr>
+        <p:style>
+          <a:lnRef idx="1">
+            <a:schemeClr val="accent1"/>
+          </a:lnRef>
+          <a:fillRef idx="3">
+            <a:schemeClr val="accent1"/>
+          </a:fillRef>
+          <a:effectRef idx="2">
+            <a:schemeClr val="accent1"/>
+          </a:effectRef>
+          <a:fontRef idx="minor">
+            <a:schemeClr val="lt1"/>
+          </a:fontRef>
+        </p:style>
+        <p:txBody>
+          <a:bodyPr rtlCol="0" anchor="ctr" wrap="square"/>
+          <a:lstStyle/>
+          <a:p>
+            <a:pPr algn="ctr"/>
+            <a:r>
+              <a:rPr sz="2200" b="1">
+                <a:solidFill>
+                  <a:srgbClr val="20302C"/>
+                </a:solidFill>
+                <a:latin typeface="Aptos"/>
+              </a:rPr>
+              <a:t>title</a:t>
+            </a:r>
+          </a:p>
+        </p:txBody>
+      </p:sp>
+      <p:sp>
+        <p:nvSpPr>
+          <p:cNvPr id="3" name="Rectangle 2"/>
+          <p:cNvSpPr/>
+          <p:nvPr/>
+        </p:nvSpPr>
+        <p:spPr>
+          <a:xfrm>
+            <a:off x="685800" y="1123188"/>
+            <a:ext cx="8887968" cy="502920"/>
+          </a:xfrm>
+          <a:prstGeom prst="rect">
+            <a:avLst/>
+          </a:prstGeom>
+          <a:solidFill>
+            <a:srgbClr val="E8E1CD"/>
+          </a:solidFill>
+          <a:ln w="19050">
+            <a:solidFill>
+              <a:srgbClr val="6E7F79"/>
+            </a:solidFill>
+          </a:ln>
+        </p:spPr>
+        <p:style>
+          <a:lnRef idx="1">
+            <a:schemeClr val="accent1"/>
+          </a:lnRef>
+          <a:fillRef idx="3">
+            <a:schemeClr val="accent1"/>
+          </a:fillRef>
+          <a:effectRef idx="2">
+            <a:schemeClr val="accent1"/>
+          </a:effectRef>
+          <a:fontRef idx="minor">
+            <a:schemeClr val="lt1"/>
+          </a:fontRef>
+        </p:style>
+        <p:txBody>
+          <a:bodyPr rtlCol="0" anchor="ctr" wrap="square"/>
+          <a:lstStyle/>
+          <a:p>
+            <a:pPr algn="ctr"/>
+            <a:r>
+              <a:rPr sz="1600" b="0">
+                <a:solidFill>
+                  <a:srgbClr val="20302C"/>
+                </a:solidFill>
+                <a:latin typeface="Aptos"/>
+              </a:rPr>
+              <a:t>key_message</a:t>
+            </a:r>
+          </a:p>
+        </p:txBody>
+      </p:sp>
+      <p:sp>
+        <p:nvSpPr>
+          <p:cNvPr id="4" name="Rectangle 3"/>
+          <p:cNvSpPr/>
+          <p:nvPr/>
+        </p:nvSpPr>
+        <p:spPr>
+          <a:xfrm>
+            <a:off x="457200" y="1699260"/>
+            <a:ext cx="1371600" cy="36576"/>
+          </a:xfrm>
+          <a:prstGeom prst="rect">
+            <a:avLst/>
+          </a:prstGeom>
+          <a:solidFill>
+            <a:srgbClr val="B8643C"/>
+          </a:solidFill>
+          <a:ln>
+            <a:noFill/>
+          </a:ln>
+        </p:spPr>
+        <p:style>
+          <a:lnRef idx="1">
+            <a:schemeClr val="accent1"/>
+          </a:lnRef>
+          <a:fillRef idx="3">
+            <a:schemeClr val="accent1"/>
+          </a:fillRef>
+          <a:effectRef idx="2">
+            <a:schemeClr val="accent1"/>
+          </a:effectRef>
+          <a:fontRef idx="minor">
+            <a:schemeClr val="lt1"/>
+          </a:fontRef>
+        </p:style>
+        <p:txBody>
+          <a:bodyPr rtlCol="0" anchor="ctr"/>
+          <a:lstStyle/>
+          <a:p>
+            <a:pPr algn="ctr"/>
+          </a:p>
+        </p:txBody>
+      </p:sp>
+      <p:sp>
+        <p:nvSpPr>
+          <p:cNvPr id="5" name="Rounded Rectangle 4"/>
+          <p:cNvSpPr/>
+          <p:nvPr/>
+        </p:nvSpPr>
+        <p:spPr>
+          <a:xfrm>
+            <a:off x="457200" y="1534668"/>
+            <a:ext cx="1115568" cy="256032"/>
+          </a:xfrm>
+          <a:prstGeom prst="roundRect">
+            <a:avLst/>
+          </a:prstGeom>
+          <a:solidFill>
+            <a:srgbClr val="E8E1CD"/>
+          </a:solidFill>
+          <a:ln w="19050">
+            <a:solidFill>
+              <a:srgbClr val="6E7F79"/>
+            </a:solidFill>
+          </a:ln>
+        </p:spPr>
+        <p:style>
+          <a:lnRef idx="1">
+            <a:schemeClr val="accent1"/>
+          </a:lnRef>
+          <a:fillRef idx="3">
+            <a:schemeClr val="accent1"/>
+          </a:fillRef>
+          <a:effectRef idx="2">
+            <a:schemeClr val="accent1"/>
+          </a:effectRef>
+          <a:fontRef idx="minor">
+            <a:schemeClr val="lt1"/>
+          </a:fontRef>
+        </p:style>
+        <p:txBody>
+          <a:bodyPr rtlCol="0" anchor="ctr" wrap="square"/>
+          <a:lstStyle/>
+          <a:p>
+            <a:pPr algn="ctr"/>
+            <a:r>
+              <a:rPr sz="1000" b="0">
+                <a:solidFill>
+                  <a:srgbClr val="20302C"/>
+                </a:solidFill>
+                <a:latin typeface="Aptos"/>
+              </a:rPr>
+              <a:t>accent</a:t>
+            </a:r>
+          </a:p>
+        </p:txBody>
+      </p:sp>
+      <p:sp>
+        <p:nvSpPr>
+          <p:cNvPr id="6" name="Oval 5"/>
+          <p:cNvSpPr/>
+          <p:nvPr/>
+        </p:nvSpPr>
+        <p:spPr>
+          <a:xfrm>
+            <a:off x="10268712" y="411480"/>
+            <a:ext cx="1463040" cy="1463040"/>
+          </a:xfrm>
+          <a:prstGeom prst="ellipse">
+            <a:avLst/>
+          </a:prstGeom>
+          <a:solidFill>
+            <a:srgbClr val="C7DCCF"/>
+          </a:solidFill>
+          <a:ln w="19050">
+            <a:solidFill>
+              <a:srgbClr val="6E7F79"/>
+            </a:solidFill>
+          </a:ln>
+        </p:spPr>
+        <p:style>
+          <a:lnRef idx="1">
+            <a:schemeClr val="accent1"/>
+          </a:lnRef>
+          <a:fillRef idx="3">
+            <a:schemeClr val="accent1"/>
+          </a:fillRef>
+          <a:effectRef idx="2">
+            <a:schemeClr val="accent1"/>
+          </a:effectRef>
+          <a:fontRef idx="minor">
+            <a:schemeClr val="lt1"/>
+          </a:fontRef>
+        </p:style>
+        <p:txBody>
+          <a:bodyPr rtlCol="0" anchor="ctr" wrap="square"/>
+          <a:lstStyle/>
+          <a:p>
+            <a:pPr algn="ctr"/>
+            <a:r>
+              <a:rPr sz="1600" b="1">
+                <a:solidFill>
+                  <a:srgbClr val="20302C"/>
+                </a:solidFill>
+                <a:latin typeface="Aptos"/>
+              </a:rPr>
+              <a:t>icon</a:t>
+            </a:r>
+          </a:p>
+        </p:txBody>
+      </p:sp>
+      <p:sp>
+        <p:nvSpPr>
+          <p:cNvPr id="7" name="Rectangle 6"/>
+          <p:cNvSpPr/>
+          <p:nvPr/>
+        </p:nvSpPr>
+        <p:spPr>
+          <a:xfrm>
+            <a:off x="457200" y="5650992"/>
+            <a:ext cx="11277295" cy="640080"/>
+          </a:xfrm>
+          <a:prstGeom prst="rect">
+            <a:avLst/>
+          </a:prstGeom>
+          <a:solidFill>
+            <a:srgbClr val="F0E8D8"/>
+          </a:solidFill>
+          <a:ln w="19050">
+            <a:solidFill>
+              <a:srgbClr val="6E7F79"/>
+            </a:solidFill>
+          </a:ln>
+        </p:spPr>
+        <p:style>
+          <a:lnRef idx="1">
+            <a:schemeClr val="accent1"/>
+          </a:lnRef>
+          <a:fillRef idx="3">
+            <a:schemeClr val="accent1"/>
+          </a:fillRef>
+          <a:effectRef idx="2">
+            <a:schemeClr val="accent1"/>
+          </a:effectRef>
+          <a:fontRef idx="minor">
+            <a:schemeClr val="lt1"/>
+          </a:fontRef>
+        </p:style>
+        <p:txBody>
+          <a:bodyPr rtlCol="0" anchor="ctr" wrap="square"/>
+          <a:lstStyle/>
+          <a:p>
+            <a:pPr algn="ctr"/>
+            <a:r>
+              <a:rPr sz="1100" b="0">
+                <a:solidFill>
+                  <a:srgbClr val="20302C"/>
+                </a:solidFill>
+                <a:latin typeface="Aptos"/>
+              </a:rPr>
+              <a:t>notes</a:t>
+            </a:r>
+          </a:p>
+        </p:txBody>
+      </p:sp>
+      <p:sp>
+        <p:nvSpPr>
+          <p:cNvPr id="8" name="Rounded Rectangle 7"/>
+          <p:cNvSpPr/>
+          <p:nvPr/>
+        </p:nvSpPr>
+        <p:spPr>
+          <a:xfrm>
+            <a:off x="457200" y="1900428"/>
+            <a:ext cx="2935224" cy="1664208"/>
+          </a:xfrm>
+          <a:prstGeom prst="roundRect">
+            <a:avLst/>
+          </a:prstGeom>
+          <a:solidFill>
+            <a:srgbClr val="D9E8E1"/>
+          </a:solidFill>
+          <a:ln w="19050">
+            <a:solidFill>
+              <a:srgbClr val="6E7F79"/>
+            </a:solidFill>
+          </a:ln>
+        </p:spPr>
+        <p:style>
+          <a:lnRef idx="1">
+            <a:schemeClr val="accent1"/>
+          </a:lnRef>
+          <a:fillRef idx="3">
+            <a:schemeClr val="accent1"/>
+          </a:fillRef>
+          <a:effectRef idx="2">
+            <a:schemeClr val="accent1"/>
+          </a:effectRef>
+          <a:fontRef idx="minor">
+            <a:schemeClr val="lt1"/>
+          </a:fontRef>
+        </p:style>
+        <p:txBody>
+          <a:bodyPr rtlCol="0" anchor="ctr" wrap="square"/>
+          <a:lstStyle/>
+          <a:p>
+            <a:pPr algn="ctr"/>
+            <a:r>
+              <a:rPr sz="1600" b="0">
+                <a:solidFill>
+                  <a:srgbClr val="20302C"/>
+                </a:solidFill>
+                <a:latin typeface="Aptos"/>
+              </a:rPr>
+              <a:t>cards</a:t>
+            </a:r>
+          </a:p>
+        </p:txBody>
+      </p:sp>
+      <p:sp>
+        <p:nvSpPr>
+          <p:cNvPr id="9" name="Rounded Rectangle 8"/>
+          <p:cNvSpPr/>
+          <p:nvPr/>
+        </p:nvSpPr>
+        <p:spPr>
+          <a:xfrm>
+            <a:off x="3666744" y="1900428"/>
+            <a:ext cx="2935224" cy="1664208"/>
+          </a:xfrm>
+          <a:prstGeom prst="roundRect">
+            <a:avLst/>
+          </a:prstGeom>
+          <a:solidFill>
+            <a:srgbClr val="D9E8E1"/>
+          </a:solidFill>
+          <a:ln w="19050">
+            <a:solidFill>
+              <a:srgbClr val="6E7F79"/>
+            </a:solidFill>
+          </a:ln>
+        </p:spPr>
+        <p:style>
+          <a:lnRef idx="1">
+            <a:schemeClr val="accent1"/>
+          </a:lnRef>
+          <a:fillRef idx="3">
+            <a:schemeClr val="accent1"/>
+          </a:fillRef>
+          <a:effectRef idx="2">
+            <a:schemeClr val="accent1"/>
+          </a:effectRef>
+          <a:fontRef idx="minor">
+            <a:schemeClr val="lt1"/>
+          </a:fontRef>
+        </p:style>
+        <p:txBody>
+          <a:bodyPr rtlCol="0" anchor="ctr" wrap="square"/>
+          <a:lstStyle/>
+          <a:p>
+            <a:pPr algn="ctr"/>
+            <a:r>
+              <a:rPr sz="1600" b="0">
+                <a:solidFill>
+                  <a:srgbClr val="20302C"/>
+                </a:solidFill>
+                <a:latin typeface="Aptos"/>
+              </a:rPr>
+              <a:t>cards</a:t>
+            </a:r>
+          </a:p>
+        </p:txBody>
+      </p:sp>
+      <p:sp>
+        <p:nvSpPr>
+          <p:cNvPr id="10" name="Rounded Rectangle 9"/>
+          <p:cNvSpPr/>
+          <p:nvPr/>
+        </p:nvSpPr>
+        <p:spPr>
+          <a:xfrm>
+            <a:off x="6876288" y="1900428"/>
+            <a:ext cx="2935224" cy="1664208"/>
+          </a:xfrm>
+          <a:prstGeom prst="roundRect">
+            <a:avLst/>
+          </a:prstGeom>
+          <a:solidFill>
+            <a:srgbClr val="D9E8E1"/>
+          </a:solidFill>
+          <a:ln w="19050">
+            <a:solidFill>
+              <a:srgbClr val="6E7F79"/>
+            </a:solidFill>
+          </a:ln>
+        </p:spPr>
+        <p:style>
+          <a:lnRef idx="1">
+            <a:schemeClr val="accent1"/>
+          </a:lnRef>
+          <a:fillRef idx="3">
+            <a:schemeClr val="accent1"/>
+          </a:fillRef>
+          <a:effectRef idx="2">
+            <a:schemeClr val="accent1"/>
+          </a:effectRef>
+          <a:fontRef idx="minor">
+            <a:schemeClr val="lt1"/>
+          </a:fontRef>
+        </p:style>
+        <p:txBody>
+          <a:bodyPr rtlCol="0" anchor="ctr" wrap="square"/>
+          <a:lstStyle/>
+          <a:p>
+            <a:pPr algn="ctr"/>
+            <a:r>
+              <a:rPr sz="1600" b="0">
+                <a:solidFill>
+                  <a:srgbClr val="20302C"/>
+                </a:solidFill>
+                <a:latin typeface="Aptos"/>
+              </a:rPr>
+              <a:t>cards</a:t>
+            </a:r>
+          </a:p>
+        </p:txBody>
+      </p:sp>
+      <p:sp>
+        <p:nvSpPr>
+          <p:cNvPr id="11" name="Rounded Rectangle 10"/>
+          <p:cNvSpPr/>
+          <p:nvPr/>
+        </p:nvSpPr>
+        <p:spPr>
+          <a:xfrm>
+            <a:off x="457200" y="3793236"/>
+            <a:ext cx="2935224" cy="1664208"/>
+          </a:xfrm>
+          <a:prstGeom prst="roundRect">
+            <a:avLst/>
+          </a:prstGeom>
+          <a:solidFill>
+            <a:srgbClr val="D9E8E1"/>
+          </a:solidFill>
+          <a:ln w="19050">
+            <a:solidFill>
+              <a:srgbClr val="6E7F79"/>
+            </a:solidFill>
+          </a:ln>
+        </p:spPr>
+        <p:style>
+          <a:lnRef idx="1">
+            <a:schemeClr val="accent1"/>
+          </a:lnRef>
+          <a:fillRef idx="3">
+            <a:schemeClr val="accent1"/>
+          </a:fillRef>
+          <a:effectRef idx="2">
+            <a:schemeClr val="accent1"/>
+          </a:effectRef>
+          <a:fontRef idx="minor">
+            <a:schemeClr val="lt1"/>
+          </a:fontRef>
+        </p:style>
+        <p:txBody>
+          <a:bodyPr rtlCol="0" anchor="ctr" wrap="square"/>
+          <a:lstStyle/>
+          <a:p>
+            <a:pPr algn="ctr"/>
+            <a:r>
+              <a:rPr sz="1600" b="0">
+                <a:solidFill>
+                  <a:srgbClr val="20302C"/>
+                </a:solidFill>
+                <a:latin typeface="Aptos"/>
+              </a:rPr>
+              <a:t>cards</a:t>
+            </a:r>
+          </a:p>
+        </p:txBody>
+      </p:sp>
+    </p:spTree>
+  </p:cSld>
+  <p:clrMapOvr>
+    <a:masterClrMapping/>
+  </p:clrMapOvr>
+</p:sld>
+</file>
+
+<file path=ppt/slides/slide28.xml><?xml version="1.0" encoding="utf-8"?>
+<p:sld xmlns:a="http://schemas.openxmlformats.org/drawingml/2006/main" xmlns:p="http://schemas.openxmlformats.org/presentationml/2006/main" xmlns:r="http://schemas.openxmlformats.org/officeDocument/2006/relationships">
+  <p:cSld>
+    <p:bg>
+      <p:bgPr>
+        <a:solidFill>
+          <a:srgbClr val="EFF5F1"/>
+        </a:solidFill>
+        <a:effectLst/>
+      </p:bgPr>
+    </p:bg>
+    <p:spTree>
+      <p:nvGrpSpPr>
+        <p:cNvPr id="1" name=""/>
+        <p:cNvGrpSpPr/>
+        <p:nvPr/>
+      </p:nvGrpSpPr>
+      <p:grpSpPr/>
+      <p:sp>
+        <p:nvSpPr>
+          <p:cNvPr id="2" name="Rounded Rectangle 1"/>
+          <p:cNvSpPr/>
+          <p:nvPr/>
+        </p:nvSpPr>
+        <p:spPr>
+          <a:xfrm>
+            <a:off x="667512" y="457200"/>
+            <a:ext cx="8083296" cy="457200"/>
+          </a:xfrm>
+          <a:prstGeom prst="roundRect">
+            <a:avLst/>
+          </a:prstGeom>
+          <a:solidFill>
+            <a:srgbClr val="CFE0D2"/>
+          </a:solidFill>
+          <a:ln w="19050">
+            <a:solidFill>
+              <a:srgbClr val="6E7F79"/>
+            </a:solidFill>
+          </a:ln>
+        </p:spPr>
+        <p:style>
+          <a:lnRef idx="1">
+            <a:schemeClr val="accent1"/>
+          </a:lnRef>
+          <a:fillRef idx="3">
+            <a:schemeClr val="accent1"/>
+          </a:fillRef>
+          <a:effectRef idx="2">
+            <a:schemeClr val="accent1"/>
+          </a:effectRef>
+          <a:fontRef idx="minor">
+            <a:schemeClr val="lt1"/>
+          </a:fontRef>
+        </p:style>
+        <p:txBody>
+          <a:bodyPr rtlCol="0" anchor="ctr" wrap="square"/>
+          <a:lstStyle/>
+          <a:p>
+            <a:pPr algn="ctr"/>
+            <a:r>
+              <a:rPr sz="2200" b="1">
+                <a:solidFill>
+                  <a:srgbClr val="20302C"/>
+                </a:solidFill>
+                <a:latin typeface="Aptos"/>
+              </a:rPr>
+              <a:t>title</a:t>
+            </a:r>
+          </a:p>
+        </p:txBody>
+      </p:sp>
+      <p:sp>
+        <p:nvSpPr>
+          <p:cNvPr id="3" name="Rectangle 2"/>
+          <p:cNvSpPr/>
+          <p:nvPr/>
+        </p:nvSpPr>
+        <p:spPr>
+          <a:xfrm>
+            <a:off x="667512" y="987552"/>
+            <a:ext cx="8083296" cy="502920"/>
+          </a:xfrm>
+          <a:prstGeom prst="rect">
+            <a:avLst/>
+          </a:prstGeom>
+          <a:solidFill>
+            <a:srgbClr val="E0ECE4"/>
+          </a:solidFill>
+          <a:ln w="19050">
+            <a:solidFill>
+              <a:srgbClr val="6E7F79"/>
+            </a:solidFill>
+          </a:ln>
+        </p:spPr>
+        <p:style>
+          <a:lnRef idx="1">
+            <a:schemeClr val="accent1"/>
+          </a:lnRef>
+          <a:fillRef idx="3">
+            <a:schemeClr val="accent1"/>
+          </a:fillRef>
+          <a:effectRef idx="2">
+            <a:schemeClr val="accent1"/>
+          </a:effectRef>
+          <a:fontRef idx="minor">
+            <a:schemeClr val="lt1"/>
+          </a:fontRef>
+        </p:style>
+        <p:txBody>
+          <a:bodyPr rtlCol="0" anchor="ctr" wrap="square"/>
+          <a:lstStyle/>
+          <a:p>
+            <a:pPr algn="ctr"/>
+            <a:r>
+              <a:rPr sz="1600" b="0">
+                <a:solidFill>
+                  <a:srgbClr val="20302C"/>
+                </a:solidFill>
+                <a:latin typeface="Aptos"/>
+              </a:rPr>
+              <a:t>key_message</a:t>
+            </a:r>
+          </a:p>
+        </p:txBody>
+      </p:sp>
+      <p:sp>
+        <p:nvSpPr>
+          <p:cNvPr id="4" name="Rectangle 3"/>
+          <p:cNvSpPr/>
+          <p:nvPr/>
+        </p:nvSpPr>
+        <p:spPr>
+          <a:xfrm>
+            <a:off x="457200" y="1563624"/>
+            <a:ext cx="1371600" cy="36576"/>
+          </a:xfrm>
+          <a:prstGeom prst="rect">
+            <a:avLst/>
+          </a:prstGeom>
+          <a:solidFill>
+            <a:srgbClr val="B8643C"/>
+          </a:solidFill>
+          <a:ln>
+            <a:noFill/>
+          </a:ln>
+        </p:spPr>
+        <p:style>
+          <a:lnRef idx="1">
+            <a:schemeClr val="accent1"/>
+          </a:lnRef>
+          <a:fillRef idx="3">
+            <a:schemeClr val="accent1"/>
+          </a:fillRef>
+          <a:effectRef idx="2">
+            <a:schemeClr val="accent1"/>
+          </a:effectRef>
+          <a:fontRef idx="minor">
+            <a:schemeClr val="lt1"/>
+          </a:fontRef>
+        </p:style>
+        <p:txBody>
+          <a:bodyPr rtlCol="0" anchor="ctr"/>
+          <a:lstStyle/>
+          <a:p>
+            <a:pPr algn="ctr"/>
+          </a:p>
+        </p:txBody>
+      </p:sp>
+      <p:sp>
+        <p:nvSpPr>
+          <p:cNvPr id="5" name="Rounded Rectangle 4"/>
+          <p:cNvSpPr/>
+          <p:nvPr/>
+        </p:nvSpPr>
+        <p:spPr>
+          <a:xfrm>
+            <a:off x="457200" y="1399032"/>
+            <a:ext cx="1115568" cy="256032"/>
+          </a:xfrm>
+          <a:prstGeom prst="roundRect">
+            <a:avLst/>
+          </a:prstGeom>
+          <a:solidFill>
+            <a:srgbClr val="E8E1CD"/>
+          </a:solidFill>
+          <a:ln w="19050">
+            <a:solidFill>
+              <a:srgbClr val="6E7F79"/>
+            </a:solidFill>
+          </a:ln>
+        </p:spPr>
+        <p:style>
+          <a:lnRef idx="1">
+            <a:schemeClr val="accent1"/>
+          </a:lnRef>
+          <a:fillRef idx="3">
+            <a:schemeClr val="accent1"/>
+          </a:fillRef>
+          <a:effectRef idx="2">
+            <a:schemeClr val="accent1"/>
+          </a:effectRef>
+          <a:fontRef idx="minor">
+            <a:schemeClr val="lt1"/>
+          </a:fontRef>
+        </p:style>
+        <p:txBody>
+          <a:bodyPr rtlCol="0" anchor="ctr" wrap="square"/>
+          <a:lstStyle/>
+          <a:p>
+            <a:pPr algn="ctr"/>
+            <a:r>
+              <a:rPr sz="1000" b="0">
+                <a:solidFill>
+                  <a:srgbClr val="20302C"/>
+                </a:solidFill>
+                <a:latin typeface="Aptos"/>
+              </a:rPr>
+              <a:t>accent</a:t>
+            </a:r>
+          </a:p>
+        </p:txBody>
+      </p:sp>
+      <p:sp>
+        <p:nvSpPr>
+          <p:cNvPr id="6" name="Rectangle 5"/>
+          <p:cNvSpPr/>
+          <p:nvPr/>
+        </p:nvSpPr>
+        <p:spPr>
+          <a:xfrm>
+            <a:off x="457200" y="5650992"/>
+            <a:ext cx="11274552" cy="640080"/>
+          </a:xfrm>
+          <a:prstGeom prst="rect">
+            <a:avLst/>
+          </a:prstGeom>
+          <a:solidFill>
+            <a:srgbClr val="E8F0EA"/>
+          </a:solidFill>
+          <a:ln w="19050">
+            <a:solidFill>
+              <a:srgbClr val="6E7F79"/>
+            </a:solidFill>
+          </a:ln>
+        </p:spPr>
+        <p:style>
+          <a:lnRef idx="1">
+            <a:schemeClr val="accent1"/>
+          </a:lnRef>
+          <a:fillRef idx="3">
+            <a:schemeClr val="accent1"/>
+          </a:fillRef>
+          <a:effectRef idx="2">
+            <a:schemeClr val="accent1"/>
+          </a:effectRef>
+          <a:fontRef idx="minor">
+            <a:schemeClr val="lt1"/>
+          </a:fontRef>
+        </p:style>
+        <p:txBody>
+          <a:bodyPr rtlCol="0" anchor="ctr" wrap="square"/>
+          <a:lstStyle/>
+          <a:p>
+            <a:pPr algn="ctr"/>
+            <a:r>
+              <a:rPr sz="1100" b="0">
+                <a:solidFill>
+                  <a:srgbClr val="20302C"/>
+                </a:solidFill>
+                <a:latin typeface="Aptos"/>
+              </a:rPr>
+              <a:t>notes</a:t>
+            </a:r>
+          </a:p>
+        </p:txBody>
+      </p:sp>
+      <p:sp>
+        <p:nvSpPr>
+          <p:cNvPr id="7" name="Oval 6"/>
+          <p:cNvSpPr/>
+          <p:nvPr/>
+        </p:nvSpPr>
+        <p:spPr>
+          <a:xfrm>
+            <a:off x="10268712" y="411480"/>
+            <a:ext cx="1463040" cy="1463040"/>
+          </a:xfrm>
+          <a:prstGeom prst="ellipse">
+            <a:avLst/>
+          </a:prstGeom>
+          <a:solidFill>
+            <a:srgbClr val="C7DCCF"/>
+          </a:solidFill>
+          <a:ln w="19050">
+            <a:solidFill>
+              <a:srgbClr val="6E7F79"/>
+            </a:solidFill>
+          </a:ln>
+        </p:spPr>
+        <p:style>
+          <a:lnRef idx="1">
+            <a:schemeClr val="accent1"/>
+          </a:lnRef>
+          <a:fillRef idx="3">
+            <a:schemeClr val="accent1"/>
+          </a:fillRef>
+          <a:effectRef idx="2">
+            <a:schemeClr val="accent1"/>
+          </a:effectRef>
+          <a:fontRef idx="minor">
+            <a:schemeClr val="lt1"/>
+          </a:fontRef>
+        </p:style>
+        <p:txBody>
+          <a:bodyPr rtlCol="0" anchor="ctr" wrap="square"/>
+          <a:lstStyle/>
+          <a:p>
+            <a:pPr algn="ctr"/>
+            <a:r>
+              <a:rPr sz="1600" b="1">
+                <a:solidFill>
+                  <a:srgbClr val="20302C"/>
+                </a:solidFill>
+                <a:latin typeface="Aptos"/>
+              </a:rPr>
+              <a:t>icon</a:t>
+            </a:r>
+          </a:p>
+        </p:txBody>
+      </p:sp>
+      <p:sp>
+        <p:nvSpPr>
+          <p:cNvPr id="8" name="Rounded Rectangle 7"/>
+          <p:cNvSpPr/>
+          <p:nvPr/>
+        </p:nvSpPr>
+        <p:spPr>
+          <a:xfrm>
+            <a:off x="457200" y="1764792"/>
+            <a:ext cx="2743200" cy="1773936"/>
+          </a:xfrm>
+          <a:prstGeom prst="roundRect">
+            <a:avLst/>
+          </a:prstGeom>
+          <a:solidFill>
+            <a:srgbClr val="D6E6DE"/>
+          </a:solidFill>
+          <a:ln w="19050">
+            <a:solidFill>
+              <a:srgbClr val="6E7F79"/>
+            </a:solidFill>
+          </a:ln>
+        </p:spPr>
+        <p:style>
+          <a:lnRef idx="1">
+            <a:schemeClr val="accent1"/>
+          </a:lnRef>
+          <a:fillRef idx="3">
+            <a:schemeClr val="accent1"/>
+          </a:fillRef>
+          <a:effectRef idx="2">
+            <a:schemeClr val="accent1"/>
+          </a:effectRef>
+          <a:fontRef idx="minor">
+            <a:schemeClr val="lt1"/>
+          </a:fontRef>
+        </p:style>
+        <p:txBody>
+          <a:bodyPr rtlCol="0" anchor="ctr" wrap="square"/>
+          <a:lstStyle/>
+          <a:p>
+            <a:pPr algn="ctr"/>
+            <a:r>
+              <a:rPr sz="1500" b="0">
+                <a:solidFill>
+                  <a:srgbClr val="20302C"/>
+                </a:solidFill>
+                <a:latin typeface="Aptos"/>
+              </a:rPr>
+              <a:t>cards</a:t>
+            </a:r>
+          </a:p>
+        </p:txBody>
+      </p:sp>
+      <p:sp>
+        <p:nvSpPr>
+          <p:cNvPr id="9" name="Rounded Rectangle 8"/>
+          <p:cNvSpPr/>
+          <p:nvPr/>
+        </p:nvSpPr>
+        <p:spPr>
+          <a:xfrm>
+            <a:off x="3474720" y="1764792"/>
+            <a:ext cx="2743200" cy="1773936"/>
+          </a:xfrm>
+          <a:prstGeom prst="roundRect">
+            <a:avLst/>
+          </a:prstGeom>
+          <a:solidFill>
+            <a:srgbClr val="D6E6DE"/>
+          </a:solidFill>
+          <a:ln w="19050">
+            <a:solidFill>
+              <a:srgbClr val="6E7F79"/>
+            </a:solidFill>
+          </a:ln>
+        </p:spPr>
+        <p:style>
+          <a:lnRef idx="1">
+            <a:schemeClr val="accent1"/>
+          </a:lnRef>
+          <a:fillRef idx="3">
+            <a:schemeClr val="accent1"/>
+          </a:fillRef>
+          <a:effectRef idx="2">
+            <a:schemeClr val="accent1"/>
+          </a:effectRef>
+          <a:fontRef idx="minor">
+            <a:schemeClr val="lt1"/>
+          </a:fontRef>
+        </p:style>
+        <p:txBody>
+          <a:bodyPr rtlCol="0" anchor="ctr" wrap="square"/>
+          <a:lstStyle/>
+          <a:p>
+            <a:pPr algn="ctr"/>
+            <a:r>
+              <a:rPr sz="1500" b="0">
+                <a:solidFill>
+                  <a:srgbClr val="20302C"/>
+                </a:solidFill>
+                <a:latin typeface="Aptos"/>
+              </a:rPr>
+              <a:t>cards</a:t>
+            </a:r>
+          </a:p>
+        </p:txBody>
+      </p:sp>
+      <p:sp>
+        <p:nvSpPr>
+          <p:cNvPr id="10" name="Rounded Rectangle 9"/>
+          <p:cNvSpPr/>
+          <p:nvPr/>
+        </p:nvSpPr>
+        <p:spPr>
+          <a:xfrm>
+            <a:off x="6492240" y="1764792"/>
+            <a:ext cx="2743200" cy="1773936"/>
+          </a:xfrm>
+          <a:prstGeom prst="roundRect">
+            <a:avLst/>
+          </a:prstGeom>
+          <a:solidFill>
+            <a:srgbClr val="D6E6DE"/>
+          </a:solidFill>
+          <a:ln w="19050">
+            <a:solidFill>
+              <a:srgbClr val="6E7F79"/>
+            </a:solidFill>
+          </a:ln>
+        </p:spPr>
+        <p:style>
+          <a:lnRef idx="1">
+            <a:schemeClr val="accent1"/>
+          </a:lnRef>
+          <a:fillRef idx="3">
+            <a:schemeClr val="accent1"/>
+          </a:fillRef>
+          <a:effectRef idx="2">
+            <a:schemeClr val="accent1"/>
+          </a:effectRef>
+          <a:fontRef idx="minor">
+            <a:schemeClr val="lt1"/>
+          </a:fontRef>
+        </p:style>
+        <p:txBody>
+          <a:bodyPr rtlCol="0" anchor="ctr" wrap="square"/>
+          <a:lstStyle/>
+          <a:p>
+            <a:pPr algn="ctr"/>
+            <a:r>
+              <a:rPr sz="1500" b="0">
+                <a:solidFill>
+                  <a:srgbClr val="20302C"/>
+                </a:solidFill>
+                <a:latin typeface="Aptos"/>
+              </a:rPr>
+              <a:t>cards</a:t>
+            </a:r>
+          </a:p>
+        </p:txBody>
+      </p:sp>
+      <p:sp>
+        <p:nvSpPr>
+          <p:cNvPr id="11" name="Rounded Rectangle 10"/>
+          <p:cNvSpPr/>
+          <p:nvPr/>
+        </p:nvSpPr>
+        <p:spPr>
+          <a:xfrm>
+            <a:off x="457200" y="3767328"/>
+            <a:ext cx="2743200" cy="1773936"/>
+          </a:xfrm>
+          <a:prstGeom prst="roundRect">
+            <a:avLst/>
+          </a:prstGeom>
+          <a:solidFill>
+            <a:srgbClr val="D6E6DE"/>
+          </a:solidFill>
+          <a:ln w="19050">
+            <a:solidFill>
+              <a:srgbClr val="6E7F79"/>
+            </a:solidFill>
+          </a:ln>
+        </p:spPr>
+        <p:style>
+          <a:lnRef idx="1">
+            <a:schemeClr val="accent1"/>
+          </a:lnRef>
+          <a:fillRef idx="3">
+            <a:schemeClr val="accent1"/>
+          </a:fillRef>
+          <a:effectRef idx="2">
+            <a:schemeClr val="accent1"/>
+          </a:effectRef>
+          <a:fontRef idx="minor">
+            <a:schemeClr val="lt1"/>
+          </a:fontRef>
+        </p:style>
+        <p:txBody>
+          <a:bodyPr rtlCol="0" anchor="ctr" wrap="square"/>
+          <a:lstStyle/>
+          <a:p>
+            <a:pPr algn="ctr"/>
+            <a:r>
+              <a:rPr sz="1500" b="0">
+                <a:solidFill>
+                  <a:srgbClr val="20302C"/>
+                </a:solidFill>
+                <a:latin typeface="Aptos"/>
+              </a:rPr>
+              <a:t>cards</a:t>
+            </a:r>
+          </a:p>
+        </p:txBody>
+      </p:sp>
+      <p:sp>
+        <p:nvSpPr>
+          <p:cNvPr id="12" name="Rounded Rectangle 11"/>
+          <p:cNvSpPr/>
+          <p:nvPr/>
+        </p:nvSpPr>
+        <p:spPr>
+          <a:xfrm>
+            <a:off x="3474720" y="3767328"/>
+            <a:ext cx="2743200" cy="1773936"/>
+          </a:xfrm>
+          <a:prstGeom prst="roundRect">
+            <a:avLst/>
+          </a:prstGeom>
+          <a:solidFill>
+            <a:srgbClr val="D6E6DE"/>
+          </a:solidFill>
+          <a:ln w="19050">
+            <a:solidFill>
+              <a:srgbClr val="6E7F79"/>
+            </a:solidFill>
+          </a:ln>
+        </p:spPr>
+        <p:style>
+          <a:lnRef idx="1">
+            <a:schemeClr val="accent1"/>
+          </a:lnRef>
+          <a:fillRef idx="3">
+            <a:schemeClr val="accent1"/>
+          </a:fillRef>
+          <a:effectRef idx="2">
+            <a:schemeClr val="accent1"/>
+          </a:effectRef>
+          <a:fontRef idx="minor">
+            <a:schemeClr val="lt1"/>
+          </a:fontRef>
+        </p:style>
+        <p:txBody>
+          <a:bodyPr rtlCol="0" anchor="ctr" wrap="square"/>
+          <a:lstStyle/>
+          <a:p>
+            <a:pPr algn="ctr"/>
+            <a:r>
+              <a:rPr sz="1500" b="0">
+                <a:solidFill>
+                  <a:srgbClr val="20302C"/>
+                </a:solidFill>
+                <a:latin typeface="Aptos"/>
+              </a:rPr>
+              <a:t>cards</a:t>
+            </a:r>
+          </a:p>
+        </p:txBody>
+      </p:sp>
+      <p:sp>
+        <p:nvSpPr>
+          <p:cNvPr id="13" name="Rounded Rectangle 12"/>
+          <p:cNvSpPr/>
+          <p:nvPr/>
+        </p:nvSpPr>
+        <p:spPr>
+          <a:xfrm>
+            <a:off x="6492240" y="3767328"/>
+            <a:ext cx="2743200" cy="1773936"/>
+          </a:xfrm>
+          <a:prstGeom prst="roundRect">
+            <a:avLst/>
+          </a:prstGeom>
+          <a:solidFill>
+            <a:srgbClr val="D6E6DE"/>
+          </a:solidFill>
+          <a:ln w="19050">
+            <a:solidFill>
+              <a:srgbClr val="6E7F79"/>
+            </a:solidFill>
+          </a:ln>
+        </p:spPr>
+        <p:style>
+          <a:lnRef idx="1">
+            <a:schemeClr val="accent1"/>
+          </a:lnRef>
+          <a:fillRef idx="3">
+            <a:schemeClr val="accent1"/>
+          </a:fillRef>
+          <a:effectRef idx="2">
+            <a:schemeClr val="accent1"/>
+          </a:effectRef>
+          <a:fontRef idx="minor">
+            <a:schemeClr val="lt1"/>
+          </a:fontRef>
+        </p:style>
+        <p:txBody>
+          <a:bodyPr rtlCol="0" anchor="ctr" wrap="square"/>
+          <a:lstStyle/>
+          <a:p>
+            <a:pPr algn="ctr"/>
+            <a:r>
+              <a:rPr sz="1500" b="0">
+                <a:solidFill>
+                  <a:srgbClr val="20302C"/>
+                </a:solidFill>
+                <a:latin typeface="Aptos"/>
+              </a:rPr>
+              <a:t>cards</a:t>
             </a:r>
           </a:p>
         </p:txBody>

</xml_diff>